<commit_message>
Innovation Urban deck v1.5: airier editorial board typography
Smaller, regular-weight annotation text with relaxed line spacing,
hand-set line breaks so phrases never split, and dot separators
between research fields.

Co-Authored-By: Claude Opus 5.5 <noreply@anthropic.com>
Claude-Session: https://claude.ai/code/session_01KcLnnCi5SsLRKaJF6PpCux
</commit_message>
<xml_diff>
--- a/Innovation_Urban/Editorial_Board_merged.pptx
+++ b/Innovation_Urban/Editorial_Board_merged.pptx
@@ -3904,7 +3904,7 @@
         </p:nvSpPr>
         <p:spPr>
           <a:xfrm>
-            <a:off x="548640" y="2286000"/>
+            <a:off x="548640" y="2249424"/>
             <a:ext cx="7315200" cy="237744"/>
           </a:xfrm>
           <a:prstGeom prst="rect">
@@ -3960,12 +3960,12 @@
         </p:nvSpPr>
         <p:spPr>
           <a:xfrm>
-            <a:off x="548640" y="2578608"/>
-            <a:ext cx="2109155" cy="1024128"/>
+            <a:off x="548640" y="2523744"/>
+            <a:ext cx="2109155" cy="1060704"/>
           </a:xfrm>
           <a:prstGeom prst="roundRect">
             <a:avLst>
-              <a:gd name="adj" fmla="val 8000"/>
+              <a:gd name="adj" fmla="val 7000"/>
             </a:avLst>
           </a:prstGeom>
           <a:solidFill>
@@ -4001,8 +4001,8 @@
         </p:blipFill>
         <p:spPr>
           <a:xfrm>
-            <a:off x="658368" y="2651760"/>
-            <a:ext cx="786384" cy="786384"/>
+            <a:off x="667512" y="2633472"/>
+            <a:ext cx="676656" cy="676656"/>
           </a:xfrm>
           <a:prstGeom prst="ellipse">
             <a:avLst/>
@@ -4022,8 +4022,8 @@
         </p:nvSpPr>
         <p:spPr>
           <a:xfrm>
-            <a:off x="832104" y="3346704"/>
-            <a:ext cx="438912" cy="192024"/>
+            <a:off x="813816" y="3218688"/>
+            <a:ext cx="384048" cy="173736"/>
           </a:xfrm>
           <a:prstGeom prst="roundRect">
             <a:avLst>
@@ -4050,7 +4050,7 @@
               <a:buNone/>
             </a:pPr>
             <a:r>
-              <a:rPr lang="en-US" altLang="zh-CN" sz="900" b="1" i="0" dirty="0">
+              <a:rPr lang="en-US" altLang="zh-CN" sz="800" b="1" i="0" spc="100" dirty="0">
                 <a:solidFill>
                   <a:srgbClr val="FFFFFF"/>
                 </a:solidFill>
@@ -4071,8 +4071,8 @@
         </p:nvSpPr>
         <p:spPr>
           <a:xfrm>
-            <a:off x="1527048" y="2633472"/>
-            <a:ext cx="1057595" cy="914400"/>
+            <a:off x="1453896" y="2596896"/>
+            <a:ext cx="1139891" cy="914400"/>
           </a:xfrm>
           <a:prstGeom prst="rect">
             <a:avLst/>
@@ -4090,12 +4090,12 @@
           <a:p>
             <a:pPr algn="l">
               <a:spcAft>
-                <a:spcPts val="200"/>
-              </a:spcAft>
-              <a:buNone/>
-            </a:pPr>
-            <a:r>
-              <a:rPr lang="en-US" altLang="zh-CN" sz="1300" b="1" i="0" dirty="0">
+                <a:spcPts val="300"/>
+              </a:spcAft>
+              <a:buNone/>
+            </a:pPr>
+            <a:r>
+              <a:rPr lang="en-US" altLang="zh-CN" sz="1250" b="1" i="0" spc="20" dirty="0">
                 <a:solidFill>
                   <a:srgbClr val="1E1E2E"/>
                 </a:solidFill>
@@ -4109,17 +4109,17 @@
           <a:p>
             <a:pPr algn="l">
               <a:lnSpc>
-                <a:spcPct val="95000"/>
+                <a:spcPct val="128000"/>
               </a:lnSpc>
               <a:spcAft>
-                <a:spcPts val="0"/>
-              </a:spcAft>
-              <a:buNone/>
-            </a:pPr>
-            <a:r>
-              <a:rPr lang="en-US" altLang="zh-CN" sz="900" b="1" i="0" dirty="0">
-                <a:solidFill>
-                  <a:srgbClr val="2E3192"/>
+                <a:spcPts val="200"/>
+              </a:spcAft>
+              <a:buNone/>
+            </a:pPr>
+            <a:r>
+              <a:rPr lang="en-US" altLang="zh-CN" sz="800" b="0" i="0" dirty="0">
+                <a:solidFill>
+                  <a:srgbClr val="4245AF"/>
                 </a:solidFill>
                 <a:latin typeface="Arial"/>
                 <a:ea typeface="Microsoft YaHei"/>
@@ -4131,7 +4131,7 @@
           <a:p>
             <a:pPr algn="l">
               <a:lnSpc>
-                <a:spcPct val="95000"/>
+                <a:spcPct val="128000"/>
               </a:lnSpc>
               <a:spcAft>
                 <a:spcPts val="0"/>
@@ -4139,7 +4139,7 @@
               <a:buNone/>
             </a:pPr>
             <a:r>
-              <a:rPr lang="en-US" altLang="zh-CN" sz="900" b="0" i="0" dirty="0">
+              <a:rPr lang="en-US" altLang="zh-CN" sz="800" b="0" i="0" dirty="0">
                 <a:solidFill>
                   <a:srgbClr val="5B5D72"/>
                 </a:solidFill>
@@ -4147,7 +4147,29 @@
                 <a:ea typeface="Microsoft YaHei"/>
                 <a:cs typeface="Arial"/>
               </a:rPr>
-              <a:t>智慧城市，地理信息系统，城市规划</a:t>
+              <a:t>智慧城市 · 城市规划</a:t>
+            </a:r>
+          </a:p>
+          <a:p>
+            <a:pPr algn="l">
+              <a:lnSpc>
+                <a:spcPct val="128000"/>
+              </a:lnSpc>
+              <a:spcAft>
+                <a:spcPts val="0"/>
+              </a:spcAft>
+              <a:buNone/>
+            </a:pPr>
+            <a:r>
+              <a:rPr lang="en-US" altLang="zh-CN" sz="800" b="0" i="0" dirty="0">
+                <a:solidFill>
+                  <a:srgbClr val="5B5D72"/>
+                </a:solidFill>
+                <a:latin typeface="Arial"/>
+                <a:ea typeface="Microsoft YaHei"/>
+                <a:cs typeface="Arial"/>
+              </a:rPr>
+              <a:t>地理信息系统</a:t>
             </a:r>
           </a:p>
         </p:txBody>
@@ -4160,12 +4182,12 @@
         </p:nvSpPr>
         <p:spPr>
           <a:xfrm>
-            <a:off x="2794955" y="2578608"/>
-            <a:ext cx="2109155" cy="1024128"/>
+            <a:off x="2794955" y="2523744"/>
+            <a:ext cx="2109155" cy="1060704"/>
           </a:xfrm>
           <a:prstGeom prst="roundRect">
             <a:avLst>
-              <a:gd name="adj" fmla="val 8000"/>
+              <a:gd name="adj" fmla="val 7000"/>
             </a:avLst>
           </a:prstGeom>
           <a:solidFill>
@@ -4202,8 +4224,8 @@
         </p:blipFill>
         <p:spPr>
           <a:xfrm>
-            <a:off x="2904683" y="2651760"/>
-            <a:ext cx="786384" cy="786384"/>
+            <a:off x="2913827" y="2633472"/>
+            <a:ext cx="676656" cy="676656"/>
           </a:xfrm>
           <a:prstGeom prst="ellipse">
             <a:avLst/>
@@ -4223,8 +4245,8 @@
         </p:nvSpPr>
         <p:spPr>
           <a:xfrm>
-            <a:off x="3078419" y="3346704"/>
-            <a:ext cx="438912" cy="192024"/>
+            <a:off x="3060131" y="3218688"/>
+            <a:ext cx="384048" cy="173736"/>
           </a:xfrm>
           <a:prstGeom prst="roundRect">
             <a:avLst>
@@ -4251,7 +4273,7 @@
               <a:buNone/>
             </a:pPr>
             <a:r>
-              <a:rPr lang="en-US" altLang="zh-CN" sz="900" b="1" i="0" dirty="0">
+              <a:rPr lang="en-US" altLang="zh-CN" sz="800" b="1" i="0" spc="100" dirty="0">
                 <a:solidFill>
                   <a:srgbClr val="FFFFFF"/>
                 </a:solidFill>
@@ -4272,8 +4294,8 @@
         </p:nvSpPr>
         <p:spPr>
           <a:xfrm>
-            <a:off x="3773363" y="2633472"/>
-            <a:ext cx="1057595" cy="914400"/>
+            <a:off x="3700211" y="2596896"/>
+            <a:ext cx="1139891" cy="914400"/>
           </a:xfrm>
           <a:prstGeom prst="rect">
             <a:avLst/>
@@ -4291,12 +4313,12 @@
           <a:p>
             <a:pPr algn="l">
               <a:spcAft>
-                <a:spcPts val="200"/>
-              </a:spcAft>
-              <a:buNone/>
-            </a:pPr>
-            <a:r>
-              <a:rPr lang="en-US" altLang="zh-CN" sz="1300" b="1" i="0" dirty="0">
+                <a:spcPts val="300"/>
+              </a:spcAft>
+              <a:buNone/>
+            </a:pPr>
+            <a:r>
+              <a:rPr lang="en-US" altLang="zh-CN" sz="1250" b="1" i="0" spc="20" dirty="0">
                 <a:solidFill>
                   <a:srgbClr val="1E1E2E"/>
                 </a:solidFill>
@@ -4310,17 +4332,17 @@
           <a:p>
             <a:pPr algn="l">
               <a:lnSpc>
-                <a:spcPct val="95000"/>
+                <a:spcPct val="128000"/>
               </a:lnSpc>
               <a:spcAft>
-                <a:spcPts val="0"/>
-              </a:spcAft>
-              <a:buNone/>
-            </a:pPr>
-            <a:r>
-              <a:rPr lang="en-US" altLang="zh-CN" sz="900" b="1" i="0" dirty="0">
-                <a:solidFill>
-                  <a:srgbClr val="2E3192"/>
+                <a:spcPts val="200"/>
+              </a:spcAft>
+              <a:buNone/>
+            </a:pPr>
+            <a:r>
+              <a:rPr lang="en-US" altLang="zh-CN" sz="800" b="0" i="0" dirty="0">
+                <a:solidFill>
+                  <a:srgbClr val="4245AF"/>
                 </a:solidFill>
                 <a:latin typeface="Arial"/>
                 <a:ea typeface="Microsoft YaHei"/>
@@ -4332,7 +4354,7 @@
           <a:p>
             <a:pPr algn="l">
               <a:lnSpc>
-                <a:spcPct val="95000"/>
+                <a:spcPct val="128000"/>
               </a:lnSpc>
               <a:spcAft>
                 <a:spcPts val="0"/>
@@ -4340,7 +4362,7 @@
               <a:buNone/>
             </a:pPr>
             <a:r>
-              <a:rPr lang="en-US" altLang="zh-CN" sz="900" b="0" i="0" dirty="0">
+              <a:rPr lang="en-US" altLang="zh-CN" sz="800" b="0" i="0" dirty="0">
                 <a:solidFill>
                   <a:srgbClr val="5B5D72"/>
                 </a:solidFill>
@@ -4348,7 +4370,29 @@
                 <a:ea typeface="Microsoft YaHei"/>
                 <a:cs typeface="Arial"/>
               </a:rPr>
-              <a:t>城市地理，城市空间，人口迁移</a:t>
+              <a:t>城市地理 · 城市空间</a:t>
+            </a:r>
+          </a:p>
+          <a:p>
+            <a:pPr algn="l">
+              <a:lnSpc>
+                <a:spcPct val="128000"/>
+              </a:lnSpc>
+              <a:spcAft>
+                <a:spcPts val="0"/>
+              </a:spcAft>
+              <a:buNone/>
+            </a:pPr>
+            <a:r>
+              <a:rPr lang="en-US" altLang="zh-CN" sz="800" b="0" i="0" dirty="0">
+                <a:solidFill>
+                  <a:srgbClr val="5B5D72"/>
+                </a:solidFill>
+                <a:latin typeface="Arial"/>
+                <a:ea typeface="Microsoft YaHei"/>
+                <a:cs typeface="Arial"/>
+              </a:rPr>
+              <a:t>人口迁移</a:t>
             </a:r>
           </a:p>
         </p:txBody>
@@ -4361,12 +4405,12 @@
         </p:nvSpPr>
         <p:spPr>
           <a:xfrm>
-            <a:off x="5041270" y="2578608"/>
-            <a:ext cx="2109155" cy="1024128"/>
+            <a:off x="5041270" y="2523744"/>
+            <a:ext cx="2109155" cy="1060704"/>
           </a:xfrm>
           <a:prstGeom prst="roundRect">
             <a:avLst>
-              <a:gd name="adj" fmla="val 8000"/>
+              <a:gd name="adj" fmla="val 7000"/>
             </a:avLst>
           </a:prstGeom>
           <a:solidFill>
@@ -4403,8 +4447,8 @@
         </p:blipFill>
         <p:spPr>
           <a:xfrm>
-            <a:off x="5150998" y="2651760"/>
-            <a:ext cx="786384" cy="786384"/>
+            <a:off x="5160142" y="2633472"/>
+            <a:ext cx="676656" cy="676656"/>
           </a:xfrm>
           <a:prstGeom prst="ellipse">
             <a:avLst/>
@@ -4424,8 +4468,8 @@
         </p:nvSpPr>
         <p:spPr>
           <a:xfrm>
-            <a:off x="5324734" y="3346704"/>
-            <a:ext cx="438912" cy="192024"/>
+            <a:off x="5306446" y="3218688"/>
+            <a:ext cx="384048" cy="173736"/>
           </a:xfrm>
           <a:prstGeom prst="roundRect">
             <a:avLst>
@@ -4452,7 +4496,7 @@
               <a:buNone/>
             </a:pPr>
             <a:r>
-              <a:rPr lang="en-US" altLang="zh-CN" sz="900" b="1" i="0" dirty="0">
+              <a:rPr lang="en-US" altLang="zh-CN" sz="800" b="1" i="0" spc="100" dirty="0">
                 <a:solidFill>
                   <a:srgbClr val="FFFFFF"/>
                 </a:solidFill>
@@ -4473,8 +4517,8 @@
         </p:nvSpPr>
         <p:spPr>
           <a:xfrm>
-            <a:off x="6019678" y="2633472"/>
-            <a:ext cx="1057595" cy="914400"/>
+            <a:off x="5946526" y="2596896"/>
+            <a:ext cx="1139891" cy="914400"/>
           </a:xfrm>
           <a:prstGeom prst="rect">
             <a:avLst/>
@@ -4492,12 +4536,12 @@
           <a:p>
             <a:pPr algn="l">
               <a:spcAft>
-                <a:spcPts val="200"/>
-              </a:spcAft>
-              <a:buNone/>
-            </a:pPr>
-            <a:r>
-              <a:rPr lang="en-US" altLang="zh-CN" sz="1300" b="1" i="0" dirty="0">
+                <a:spcPts val="300"/>
+              </a:spcAft>
+              <a:buNone/>
+            </a:pPr>
+            <a:r>
+              <a:rPr lang="en-US" altLang="zh-CN" sz="1250" b="1" i="0" spc="20" dirty="0">
                 <a:solidFill>
                   <a:srgbClr val="1E1E2E"/>
                 </a:solidFill>
@@ -4511,17 +4555,17 @@
           <a:p>
             <a:pPr algn="l">
               <a:lnSpc>
-                <a:spcPct val="95000"/>
+                <a:spcPct val="128000"/>
               </a:lnSpc>
               <a:spcAft>
-                <a:spcPts val="0"/>
-              </a:spcAft>
-              <a:buNone/>
-            </a:pPr>
-            <a:r>
-              <a:rPr lang="en-US" altLang="zh-CN" sz="900" b="1" i="0" dirty="0">
-                <a:solidFill>
-                  <a:srgbClr val="2E3192"/>
+                <a:spcPts val="200"/>
+              </a:spcAft>
+              <a:buNone/>
+            </a:pPr>
+            <a:r>
+              <a:rPr lang="en-US" altLang="zh-CN" sz="800" b="0" i="0" dirty="0">
+                <a:solidFill>
+                  <a:srgbClr val="4245AF"/>
                 </a:solidFill>
                 <a:latin typeface="Arial"/>
                 <a:ea typeface="Microsoft YaHei"/>
@@ -4533,7 +4577,7 @@
           <a:p>
             <a:pPr algn="l">
               <a:lnSpc>
-                <a:spcPct val="95000"/>
+                <a:spcPct val="128000"/>
               </a:lnSpc>
               <a:spcAft>
                 <a:spcPts val="0"/>
@@ -4541,7 +4585,7 @@
               <a:buNone/>
             </a:pPr>
             <a:r>
-              <a:rPr lang="en-US" altLang="zh-CN" sz="900" b="0" i="0" dirty="0">
+              <a:rPr lang="en-US" altLang="zh-CN" sz="800" b="0" i="0" dirty="0">
                 <a:solidFill>
                   <a:srgbClr val="5B5D72"/>
                 </a:solidFill>
@@ -4549,7 +4593,7 @@
                 <a:ea typeface="Microsoft YaHei"/>
                 <a:cs typeface="Arial"/>
               </a:rPr>
-              <a:t>城市规划，城市治理</a:t>
+              <a:t>城市规划 · 城市治理</a:t>
             </a:r>
           </a:p>
         </p:txBody>
@@ -4562,12 +4606,12 @@
         </p:nvSpPr>
         <p:spPr>
           <a:xfrm>
-            <a:off x="7287585" y="2578608"/>
-            <a:ext cx="2109155" cy="1024128"/>
+            <a:off x="7287585" y="2523744"/>
+            <a:ext cx="2109155" cy="1060704"/>
           </a:xfrm>
           <a:prstGeom prst="roundRect">
             <a:avLst>
-              <a:gd name="adj" fmla="val 8000"/>
+              <a:gd name="adj" fmla="val 7000"/>
             </a:avLst>
           </a:prstGeom>
           <a:solidFill>
@@ -4604,8 +4648,8 @@
         </p:blipFill>
         <p:spPr>
           <a:xfrm>
-            <a:off x="7397313" y="2651760"/>
-            <a:ext cx="786384" cy="786384"/>
+            <a:off x="7406457" y="2633472"/>
+            <a:ext cx="676656" cy="676656"/>
           </a:xfrm>
           <a:prstGeom prst="ellipse">
             <a:avLst/>
@@ -4625,8 +4669,8 @@
         </p:nvSpPr>
         <p:spPr>
           <a:xfrm>
-            <a:off x="7571049" y="3346704"/>
-            <a:ext cx="438912" cy="192024"/>
+            <a:off x="7552761" y="3218688"/>
+            <a:ext cx="384048" cy="173736"/>
           </a:xfrm>
           <a:prstGeom prst="roundRect">
             <a:avLst>
@@ -4653,7 +4697,7 @@
               <a:buNone/>
             </a:pPr>
             <a:r>
-              <a:rPr lang="en-US" altLang="zh-CN" sz="900" b="1" i="0" dirty="0">
+              <a:rPr lang="en-US" altLang="zh-CN" sz="800" b="1" i="0" spc="100" dirty="0">
                 <a:solidFill>
                   <a:srgbClr val="FFFFFF"/>
                 </a:solidFill>
@@ -4674,8 +4718,8 @@
         </p:nvSpPr>
         <p:spPr>
           <a:xfrm>
-            <a:off x="8265993" y="2633472"/>
-            <a:ext cx="1057595" cy="914400"/>
+            <a:off x="8192841" y="2596896"/>
+            <a:ext cx="1139891" cy="914400"/>
           </a:xfrm>
           <a:prstGeom prst="rect">
             <a:avLst/>
@@ -4693,12 +4737,12 @@
           <a:p>
             <a:pPr algn="l">
               <a:spcAft>
-                <a:spcPts val="200"/>
-              </a:spcAft>
-              <a:buNone/>
-            </a:pPr>
-            <a:r>
-              <a:rPr lang="en-US" altLang="zh-CN" sz="1300" b="1" i="0" dirty="0">
+                <a:spcPts val="300"/>
+              </a:spcAft>
+              <a:buNone/>
+            </a:pPr>
+            <a:r>
+              <a:rPr lang="en-US" altLang="zh-CN" sz="1250" b="1" i="0" spc="20" dirty="0">
                 <a:solidFill>
                   <a:srgbClr val="1E1E2E"/>
                 </a:solidFill>
@@ -4712,7 +4756,7 @@
           <a:p>
             <a:pPr algn="l">
               <a:lnSpc>
-                <a:spcPct val="95000"/>
+                <a:spcPct val="128000"/>
               </a:lnSpc>
               <a:spcAft>
                 <a:spcPts val="0"/>
@@ -4720,29 +4764,51 @@
               <a:buNone/>
             </a:pPr>
             <a:r>
-              <a:rPr lang="en-US" altLang="zh-CN" sz="900" b="1" i="0" dirty="0">
-                <a:solidFill>
-                  <a:srgbClr val="2E3192"/>
-                </a:solidFill>
-                <a:latin typeface="Arial"/>
-                <a:ea typeface="Microsoft YaHei"/>
-                <a:cs typeface="Arial"/>
-              </a:rPr>
-              <a:t>中国科学院生态环境研究中心</a:t>
+              <a:rPr lang="en-US" altLang="zh-CN" sz="800" b="0" i="0" dirty="0">
+                <a:solidFill>
+                  <a:srgbClr val="4245AF"/>
+                </a:solidFill>
+                <a:latin typeface="Arial"/>
+                <a:ea typeface="Microsoft YaHei"/>
+                <a:cs typeface="Arial"/>
+              </a:rPr>
+              <a:t>中国科学院</a:t>
             </a:r>
           </a:p>
           <a:p>
             <a:pPr algn="l">
               <a:lnSpc>
-                <a:spcPct val="95000"/>
+                <a:spcPct val="128000"/>
               </a:lnSpc>
               <a:spcAft>
+                <a:spcPts val="200"/>
+              </a:spcAft>
+              <a:buNone/>
+            </a:pPr>
+            <a:r>
+              <a:rPr lang="en-US" altLang="zh-CN" sz="800" b="0" i="0" dirty="0">
+                <a:solidFill>
+                  <a:srgbClr val="4245AF"/>
+                </a:solidFill>
+                <a:latin typeface="Arial"/>
+                <a:ea typeface="Microsoft YaHei"/>
+                <a:cs typeface="Arial"/>
+              </a:rPr>
+              <a:t>生态环境研究中心</a:t>
+            </a:r>
+          </a:p>
+          <a:p>
+            <a:pPr algn="l">
+              <a:lnSpc>
+                <a:spcPct val="128000"/>
+              </a:lnSpc>
+              <a:spcAft>
                 <a:spcPts val="0"/>
               </a:spcAft>
               <a:buNone/>
             </a:pPr>
             <a:r>
-              <a:rPr lang="en-US" altLang="zh-CN" sz="900" b="0" i="0" dirty="0">
+              <a:rPr lang="en-US" altLang="zh-CN" sz="800" b="0" i="0" dirty="0">
                 <a:solidFill>
                   <a:srgbClr val="5B5D72"/>
                 </a:solidFill>
@@ -4750,7 +4816,29 @@
                 <a:ea typeface="Microsoft YaHei"/>
                 <a:cs typeface="Arial"/>
               </a:rPr>
-              <a:t>景观生态、生态系统服务</a:t>
+              <a:t>景观生态</a:t>
+            </a:r>
+          </a:p>
+          <a:p>
+            <a:pPr algn="l">
+              <a:lnSpc>
+                <a:spcPct val="128000"/>
+              </a:lnSpc>
+              <a:spcAft>
+                <a:spcPts val="0"/>
+              </a:spcAft>
+              <a:buNone/>
+            </a:pPr>
+            <a:r>
+              <a:rPr lang="en-US" altLang="zh-CN" sz="800" b="0" i="0" dirty="0">
+                <a:solidFill>
+                  <a:srgbClr val="5B5D72"/>
+                </a:solidFill>
+                <a:latin typeface="Arial"/>
+                <a:ea typeface="Microsoft YaHei"/>
+                <a:cs typeface="Arial"/>
+              </a:rPr>
+              <a:t>生态系统服务</a:t>
             </a:r>
           </a:p>
         </p:txBody>
@@ -4763,12 +4851,12 @@
         </p:nvSpPr>
         <p:spPr>
           <a:xfrm>
-            <a:off x="9533900" y="2578608"/>
-            <a:ext cx="2109155" cy="1024128"/>
+            <a:off x="9533900" y="2523744"/>
+            <a:ext cx="2109155" cy="1060704"/>
           </a:xfrm>
           <a:prstGeom prst="roundRect">
             <a:avLst>
-              <a:gd name="adj" fmla="val 8000"/>
+              <a:gd name="adj" fmla="val 7000"/>
             </a:avLst>
           </a:prstGeom>
           <a:solidFill>
@@ -4805,8 +4893,8 @@
         </p:blipFill>
         <p:spPr>
           <a:xfrm>
-            <a:off x="9643628" y="2651760"/>
-            <a:ext cx="786384" cy="786384"/>
+            <a:off x="9652772" y="2633472"/>
+            <a:ext cx="676656" cy="676656"/>
           </a:xfrm>
           <a:prstGeom prst="ellipse">
             <a:avLst/>
@@ -4826,8 +4914,8 @@
         </p:nvSpPr>
         <p:spPr>
           <a:xfrm>
-            <a:off x="9817364" y="3346704"/>
-            <a:ext cx="438912" cy="192024"/>
+            <a:off x="9799076" y="3218688"/>
+            <a:ext cx="384048" cy="173736"/>
           </a:xfrm>
           <a:prstGeom prst="roundRect">
             <a:avLst>
@@ -4854,7 +4942,7 @@
               <a:buNone/>
             </a:pPr>
             <a:r>
-              <a:rPr lang="en-US" altLang="zh-CN" sz="900" b="1" i="0" dirty="0">
+              <a:rPr lang="en-US" altLang="zh-CN" sz="800" b="1" i="0" spc="100" dirty="0">
                 <a:solidFill>
                   <a:srgbClr val="FFFFFF"/>
                 </a:solidFill>
@@ -4875,8 +4963,8 @@
         </p:nvSpPr>
         <p:spPr>
           <a:xfrm>
-            <a:off x="10512308" y="2633472"/>
-            <a:ext cx="1057595" cy="914400"/>
+            <a:off x="10439156" y="2596896"/>
+            <a:ext cx="1139891" cy="914400"/>
           </a:xfrm>
           <a:prstGeom prst="rect">
             <a:avLst/>
@@ -4894,12 +4982,12 @@
           <a:p>
             <a:pPr algn="l">
               <a:spcAft>
-                <a:spcPts val="200"/>
-              </a:spcAft>
-              <a:buNone/>
-            </a:pPr>
-            <a:r>
-              <a:rPr lang="en-US" altLang="zh-CN" sz="1300" b="1" i="0" dirty="0">
+                <a:spcPts val="300"/>
+              </a:spcAft>
+              <a:buNone/>
+            </a:pPr>
+            <a:r>
+              <a:rPr lang="en-US" altLang="zh-CN" sz="1250" b="1" i="0" spc="20" dirty="0">
                 <a:solidFill>
                   <a:srgbClr val="1E1E2E"/>
                 </a:solidFill>
@@ -4913,17 +5001,17 @@
           <a:p>
             <a:pPr algn="l">
               <a:lnSpc>
-                <a:spcPct val="95000"/>
+                <a:spcPct val="128000"/>
               </a:lnSpc>
               <a:spcAft>
-                <a:spcPts val="0"/>
-              </a:spcAft>
-              <a:buNone/>
-            </a:pPr>
-            <a:r>
-              <a:rPr lang="en-US" altLang="zh-CN" sz="900" b="1" i="0" dirty="0">
-                <a:solidFill>
-                  <a:srgbClr val="2E3192"/>
+                <a:spcPts val="200"/>
+              </a:spcAft>
+              <a:buNone/>
+            </a:pPr>
+            <a:r>
+              <a:rPr lang="en-US" altLang="zh-CN" sz="800" b="0" i="0" dirty="0">
+                <a:solidFill>
+                  <a:srgbClr val="4245AF"/>
                 </a:solidFill>
                 <a:latin typeface="Arial"/>
                 <a:ea typeface="Microsoft YaHei"/>
@@ -4935,7 +5023,7 @@
           <a:p>
             <a:pPr algn="l">
               <a:lnSpc>
-                <a:spcPct val="95000"/>
+                <a:spcPct val="128000"/>
               </a:lnSpc>
               <a:spcAft>
                 <a:spcPts val="0"/>
@@ -4943,7 +5031,7 @@
               <a:buNone/>
             </a:pPr>
             <a:r>
-              <a:rPr lang="en-US" altLang="zh-CN" sz="900" b="0" i="0" dirty="0">
+              <a:rPr lang="en-US" altLang="zh-CN" sz="800" b="0" i="0" dirty="0">
                 <a:solidFill>
                   <a:srgbClr val="5B5D72"/>
                 </a:solidFill>
@@ -4951,7 +5039,29 @@
                 <a:ea typeface="Microsoft YaHei"/>
                 <a:cs typeface="Arial"/>
               </a:rPr>
-              <a:t>国土空间规划、区域发展</a:t>
+              <a:t>国土空间规划</a:t>
+            </a:r>
+          </a:p>
+          <a:p>
+            <a:pPr algn="l">
+              <a:lnSpc>
+                <a:spcPct val="128000"/>
+              </a:lnSpc>
+              <a:spcAft>
+                <a:spcPts val="0"/>
+              </a:spcAft>
+              <a:buNone/>
+            </a:pPr>
+            <a:r>
+              <a:rPr lang="en-US" altLang="zh-CN" sz="800" b="0" i="0" dirty="0">
+                <a:solidFill>
+                  <a:srgbClr val="5B5D72"/>
+                </a:solidFill>
+                <a:latin typeface="Arial"/>
+                <a:ea typeface="Microsoft YaHei"/>
+                <a:cs typeface="Arial"/>
+              </a:rPr>
+              <a:t>区域发展</a:t>
             </a:r>
           </a:p>
         </p:txBody>
@@ -4964,12 +5074,12 @@
         </p:nvSpPr>
         <p:spPr>
           <a:xfrm>
-            <a:off x="548640" y="3694176"/>
-            <a:ext cx="2109155" cy="1024128"/>
+            <a:off x="548640" y="3675888"/>
+            <a:ext cx="2109155" cy="1060704"/>
           </a:xfrm>
           <a:prstGeom prst="roundRect">
             <a:avLst>
-              <a:gd name="adj" fmla="val 8000"/>
+              <a:gd name="adj" fmla="val 7000"/>
             </a:avLst>
           </a:prstGeom>
           <a:solidFill>
@@ -5006,8 +5116,8 @@
         </p:blipFill>
         <p:spPr>
           <a:xfrm>
-            <a:off x="658368" y="3767328"/>
-            <a:ext cx="786384" cy="786384"/>
+            <a:off x="667512" y="3785616"/>
+            <a:ext cx="676656" cy="676656"/>
           </a:xfrm>
           <a:prstGeom prst="ellipse">
             <a:avLst/>
@@ -5027,8 +5137,8 @@
         </p:nvSpPr>
         <p:spPr>
           <a:xfrm>
-            <a:off x="832104" y="4462272"/>
-            <a:ext cx="438912" cy="192024"/>
+            <a:off x="813816" y="4370832"/>
+            <a:ext cx="384048" cy="173736"/>
           </a:xfrm>
           <a:prstGeom prst="roundRect">
             <a:avLst>
@@ -5055,7 +5165,7 @@
               <a:buNone/>
             </a:pPr>
             <a:r>
-              <a:rPr lang="en-US" altLang="zh-CN" sz="900" b="1" i="0" dirty="0">
+              <a:rPr lang="en-US" altLang="zh-CN" sz="800" b="1" i="0" spc="100" dirty="0">
                 <a:solidFill>
                   <a:srgbClr val="FFFFFF"/>
                 </a:solidFill>
@@ -5076,8 +5186,8 @@
         </p:nvSpPr>
         <p:spPr>
           <a:xfrm>
-            <a:off x="1527048" y="3749040"/>
-            <a:ext cx="1057595" cy="914400"/>
+            <a:off x="1453896" y="3749040"/>
+            <a:ext cx="1139891" cy="914400"/>
           </a:xfrm>
           <a:prstGeom prst="rect">
             <a:avLst/>
@@ -5095,12 +5205,12 @@
           <a:p>
             <a:pPr algn="l">
               <a:spcAft>
-                <a:spcPts val="200"/>
-              </a:spcAft>
-              <a:buNone/>
-            </a:pPr>
-            <a:r>
-              <a:rPr lang="en-US" altLang="zh-CN" sz="1300" b="1" i="0" dirty="0">
+                <a:spcPts val="300"/>
+              </a:spcAft>
+              <a:buNone/>
+            </a:pPr>
+            <a:r>
+              <a:rPr lang="en-US" altLang="zh-CN" sz="1250" b="1" i="0" spc="20" dirty="0">
                 <a:solidFill>
                   <a:srgbClr val="1E1E2E"/>
                 </a:solidFill>
@@ -5114,17 +5224,17 @@
           <a:p>
             <a:pPr algn="l">
               <a:lnSpc>
-                <a:spcPct val="95000"/>
+                <a:spcPct val="128000"/>
               </a:lnSpc>
               <a:spcAft>
-                <a:spcPts val="0"/>
-              </a:spcAft>
-              <a:buNone/>
-            </a:pPr>
-            <a:r>
-              <a:rPr lang="en-US" altLang="zh-CN" sz="900" b="1" i="0" dirty="0">
-                <a:solidFill>
-                  <a:srgbClr val="2E3192"/>
+                <a:spcPts val="200"/>
+              </a:spcAft>
+              <a:buNone/>
+            </a:pPr>
+            <a:r>
+              <a:rPr lang="en-US" altLang="zh-CN" sz="800" b="0" i="0" dirty="0">
+                <a:solidFill>
+                  <a:srgbClr val="4245AF"/>
                 </a:solidFill>
                 <a:latin typeface="Arial"/>
                 <a:ea typeface="Microsoft YaHei"/>
@@ -5136,7 +5246,7 @@
           <a:p>
             <a:pPr algn="l">
               <a:lnSpc>
-                <a:spcPct val="95000"/>
+                <a:spcPct val="128000"/>
               </a:lnSpc>
               <a:spcAft>
                 <a:spcPts val="0"/>
@@ -5144,7 +5254,7 @@
               <a:buNone/>
             </a:pPr>
             <a:r>
-              <a:rPr lang="en-US" altLang="zh-CN" sz="900" b="0" i="0" dirty="0">
+              <a:rPr lang="en-US" altLang="zh-CN" sz="800" b="0" i="0" dirty="0">
                 <a:solidFill>
                   <a:srgbClr val="5B5D72"/>
                 </a:solidFill>
@@ -5152,7 +5262,29 @@
                 <a:ea typeface="Microsoft YaHei"/>
                 <a:cs typeface="Arial"/>
               </a:rPr>
-              <a:t>遥感，全球环境变化，城市化与健康</a:t>
+              <a:t>遥感 · 全球环境变化</a:t>
+            </a:r>
+          </a:p>
+          <a:p>
+            <a:pPr algn="l">
+              <a:lnSpc>
+                <a:spcPct val="128000"/>
+              </a:lnSpc>
+              <a:spcAft>
+                <a:spcPts val="0"/>
+              </a:spcAft>
+              <a:buNone/>
+            </a:pPr>
+            <a:r>
+              <a:rPr lang="en-US" altLang="zh-CN" sz="800" b="0" i="0" dirty="0">
+                <a:solidFill>
+                  <a:srgbClr val="5B5D72"/>
+                </a:solidFill>
+                <a:latin typeface="Arial"/>
+                <a:ea typeface="Microsoft YaHei"/>
+                <a:cs typeface="Arial"/>
+              </a:rPr>
+              <a:t>城市化与健康</a:t>
             </a:r>
           </a:p>
         </p:txBody>
@@ -5165,12 +5297,12 @@
         </p:nvSpPr>
         <p:spPr>
           <a:xfrm>
-            <a:off x="2794955" y="3694176"/>
-            <a:ext cx="2109155" cy="1024128"/>
+            <a:off x="2794955" y="3675888"/>
+            <a:ext cx="2109155" cy="1060704"/>
           </a:xfrm>
           <a:prstGeom prst="roundRect">
             <a:avLst>
-              <a:gd name="adj" fmla="val 8000"/>
+              <a:gd name="adj" fmla="val 7000"/>
             </a:avLst>
           </a:prstGeom>
           <a:solidFill>
@@ -5207,8 +5339,8 @@
         </p:blipFill>
         <p:spPr>
           <a:xfrm>
-            <a:off x="2904683" y="3767328"/>
-            <a:ext cx="786384" cy="786384"/>
+            <a:off x="2913827" y="3785616"/>
+            <a:ext cx="676656" cy="676656"/>
           </a:xfrm>
           <a:prstGeom prst="ellipse">
             <a:avLst/>
@@ -5228,8 +5360,8 @@
         </p:nvSpPr>
         <p:spPr>
           <a:xfrm>
-            <a:off x="3078419" y="4462272"/>
-            <a:ext cx="438912" cy="192024"/>
+            <a:off x="3060131" y="4370832"/>
+            <a:ext cx="384048" cy="173736"/>
           </a:xfrm>
           <a:prstGeom prst="roundRect">
             <a:avLst>
@@ -5256,7 +5388,7 @@
               <a:buNone/>
             </a:pPr>
             <a:r>
-              <a:rPr lang="en-US" altLang="zh-CN" sz="900" b="1" i="0" dirty="0">
+              <a:rPr lang="en-US" altLang="zh-CN" sz="800" b="1" i="0" spc="100" dirty="0">
                 <a:solidFill>
                   <a:srgbClr val="FFFFFF"/>
                 </a:solidFill>
@@ -5277,8 +5409,8 @@
         </p:nvSpPr>
         <p:spPr>
           <a:xfrm>
-            <a:off x="3773363" y="3749040"/>
-            <a:ext cx="1057595" cy="914400"/>
+            <a:off x="3700211" y="3749040"/>
+            <a:ext cx="1139891" cy="914400"/>
           </a:xfrm>
           <a:prstGeom prst="rect">
             <a:avLst/>
@@ -5296,12 +5428,12 @@
           <a:p>
             <a:pPr algn="l">
               <a:spcAft>
-                <a:spcPts val="200"/>
-              </a:spcAft>
-              <a:buNone/>
-            </a:pPr>
-            <a:r>
-              <a:rPr lang="en-US" altLang="zh-CN" sz="1300" b="1" i="0" dirty="0">
+                <a:spcPts val="300"/>
+              </a:spcAft>
+              <a:buNone/>
+            </a:pPr>
+            <a:r>
+              <a:rPr lang="en-US" altLang="zh-CN" sz="1250" b="1" i="0" spc="20" dirty="0">
                 <a:solidFill>
                   <a:srgbClr val="1E1E2E"/>
                 </a:solidFill>
@@ -5315,17 +5447,17 @@
           <a:p>
             <a:pPr algn="l">
               <a:lnSpc>
-                <a:spcPct val="95000"/>
+                <a:spcPct val="128000"/>
               </a:lnSpc>
               <a:spcAft>
-                <a:spcPts val="0"/>
-              </a:spcAft>
-              <a:buNone/>
-            </a:pPr>
-            <a:r>
-              <a:rPr lang="en-US" altLang="zh-CN" sz="900" b="1" i="0" dirty="0">
-                <a:solidFill>
-                  <a:srgbClr val="2E3192"/>
+                <a:spcPts val="200"/>
+              </a:spcAft>
+              <a:buNone/>
+            </a:pPr>
+            <a:r>
+              <a:rPr lang="en-US" altLang="zh-CN" sz="800" b="0" i="0" dirty="0">
+                <a:solidFill>
+                  <a:srgbClr val="4245AF"/>
                 </a:solidFill>
                 <a:latin typeface="Arial"/>
                 <a:ea typeface="Microsoft YaHei"/>
@@ -5337,7 +5469,7 @@
           <a:p>
             <a:pPr algn="l">
               <a:lnSpc>
-                <a:spcPct val="95000"/>
+                <a:spcPct val="128000"/>
               </a:lnSpc>
               <a:spcAft>
                 <a:spcPts val="0"/>
@@ -5345,7 +5477,7 @@
               <a:buNone/>
             </a:pPr>
             <a:r>
-              <a:rPr lang="en-US" altLang="zh-CN" sz="900" b="0" i="0" dirty="0">
+              <a:rPr lang="en-US" altLang="zh-CN" sz="800" b="0" i="0" dirty="0">
                 <a:solidFill>
                   <a:srgbClr val="5B5D72"/>
                 </a:solidFill>
@@ -5353,7 +5485,51 @@
                 <a:ea typeface="Microsoft YaHei"/>
                 <a:cs typeface="Arial"/>
               </a:rPr>
-              <a:t>地球系统科学、全球环境变化、气候动力学与数值模拟</a:t>
+              <a:t>地球系统科学</a:t>
+            </a:r>
+          </a:p>
+          <a:p>
+            <a:pPr algn="l">
+              <a:lnSpc>
+                <a:spcPct val="128000"/>
+              </a:lnSpc>
+              <a:spcAft>
+                <a:spcPts val="0"/>
+              </a:spcAft>
+              <a:buNone/>
+            </a:pPr>
+            <a:r>
+              <a:rPr lang="en-US" altLang="zh-CN" sz="800" b="0" i="0" dirty="0">
+                <a:solidFill>
+                  <a:srgbClr val="5B5D72"/>
+                </a:solidFill>
+                <a:latin typeface="Arial"/>
+                <a:ea typeface="Microsoft YaHei"/>
+                <a:cs typeface="Arial"/>
+              </a:rPr>
+              <a:t>全球环境变化</a:t>
+            </a:r>
+          </a:p>
+          <a:p>
+            <a:pPr algn="l">
+              <a:lnSpc>
+                <a:spcPct val="128000"/>
+              </a:lnSpc>
+              <a:spcAft>
+                <a:spcPts val="0"/>
+              </a:spcAft>
+              <a:buNone/>
+            </a:pPr>
+            <a:r>
+              <a:rPr lang="en-US" altLang="zh-CN" sz="800" b="0" i="0" dirty="0">
+                <a:solidFill>
+                  <a:srgbClr val="5B5D72"/>
+                </a:solidFill>
+                <a:latin typeface="Arial"/>
+                <a:ea typeface="Microsoft YaHei"/>
+                <a:cs typeface="Arial"/>
+              </a:rPr>
+              <a:t>气候动力学与数值模拟</a:t>
             </a:r>
           </a:p>
         </p:txBody>
@@ -5366,12 +5542,12 @@
         </p:nvSpPr>
         <p:spPr>
           <a:xfrm>
-            <a:off x="5041270" y="3694176"/>
-            <a:ext cx="2109155" cy="1024128"/>
+            <a:off x="5041270" y="3675888"/>
+            <a:ext cx="2109155" cy="1060704"/>
           </a:xfrm>
           <a:prstGeom prst="roundRect">
             <a:avLst>
-              <a:gd name="adj" fmla="val 8000"/>
+              <a:gd name="adj" fmla="val 7000"/>
             </a:avLst>
           </a:prstGeom>
           <a:solidFill>
@@ -5408,8 +5584,8 @@
         </p:blipFill>
         <p:spPr>
           <a:xfrm>
-            <a:off x="5150998" y="3767328"/>
-            <a:ext cx="786384" cy="786384"/>
+            <a:off x="5160142" y="3785616"/>
+            <a:ext cx="676656" cy="676656"/>
           </a:xfrm>
           <a:prstGeom prst="ellipse">
             <a:avLst/>
@@ -5429,8 +5605,8 @@
         </p:nvSpPr>
         <p:spPr>
           <a:xfrm>
-            <a:off x="5324734" y="4462272"/>
-            <a:ext cx="438912" cy="192024"/>
+            <a:off x="5306446" y="4370832"/>
+            <a:ext cx="384048" cy="173736"/>
           </a:xfrm>
           <a:prstGeom prst="roundRect">
             <a:avLst>
@@ -5457,7 +5633,7 @@
               <a:buNone/>
             </a:pPr>
             <a:r>
-              <a:rPr lang="en-US" altLang="zh-CN" sz="900" b="1" i="0" dirty="0">
+              <a:rPr lang="en-US" altLang="zh-CN" sz="800" b="1" i="0" spc="100" dirty="0">
                 <a:solidFill>
                   <a:srgbClr val="FFFFFF"/>
                 </a:solidFill>
@@ -5478,8 +5654,8 @@
         </p:nvSpPr>
         <p:spPr>
           <a:xfrm>
-            <a:off x="6019678" y="3749040"/>
-            <a:ext cx="1057595" cy="914400"/>
+            <a:off x="5946526" y="3749040"/>
+            <a:ext cx="1139891" cy="914400"/>
           </a:xfrm>
           <a:prstGeom prst="rect">
             <a:avLst/>
@@ -5497,12 +5673,12 @@
           <a:p>
             <a:pPr algn="l">
               <a:spcAft>
-                <a:spcPts val="200"/>
-              </a:spcAft>
-              <a:buNone/>
-            </a:pPr>
-            <a:r>
-              <a:rPr lang="en-US" altLang="zh-CN" sz="1300" b="1" i="0" dirty="0">
+                <a:spcPts val="300"/>
+              </a:spcAft>
+              <a:buNone/>
+            </a:pPr>
+            <a:r>
+              <a:rPr lang="en-US" altLang="zh-CN" sz="1250" b="1" i="0" spc="20" dirty="0">
                 <a:solidFill>
                   <a:srgbClr val="1E1E2E"/>
                 </a:solidFill>
@@ -5516,17 +5692,17 @@
           <a:p>
             <a:pPr algn="l">
               <a:lnSpc>
-                <a:spcPct val="95000"/>
+                <a:spcPct val="128000"/>
               </a:lnSpc>
               <a:spcAft>
-                <a:spcPts val="0"/>
-              </a:spcAft>
-              <a:buNone/>
-            </a:pPr>
-            <a:r>
-              <a:rPr lang="en-US" altLang="zh-CN" sz="900" b="1" i="0" dirty="0">
-                <a:solidFill>
-                  <a:srgbClr val="2E3192"/>
+                <a:spcPts val="200"/>
+              </a:spcAft>
+              <a:buNone/>
+            </a:pPr>
+            <a:r>
+              <a:rPr lang="en-US" altLang="zh-CN" sz="800" b="0" i="0" dirty="0">
+                <a:solidFill>
+                  <a:srgbClr val="4245AF"/>
                 </a:solidFill>
                 <a:latin typeface="Arial"/>
                 <a:ea typeface="Microsoft YaHei"/>
@@ -5538,7 +5714,7 @@
           <a:p>
             <a:pPr algn="l">
               <a:lnSpc>
-                <a:spcPct val="95000"/>
+                <a:spcPct val="128000"/>
               </a:lnSpc>
               <a:spcAft>
                 <a:spcPts val="0"/>
@@ -5546,7 +5722,7 @@
               <a:buNone/>
             </a:pPr>
             <a:r>
-              <a:rPr lang="en-US" altLang="zh-CN" sz="900" b="0" i="0" dirty="0">
+              <a:rPr lang="en-US" altLang="zh-CN" sz="800" b="0" i="0" dirty="0">
                 <a:solidFill>
                   <a:srgbClr val="5B5D72"/>
                 </a:solidFill>
@@ -5554,7 +5730,29 @@
                 <a:ea typeface="Microsoft YaHei"/>
                 <a:cs typeface="Arial"/>
               </a:rPr>
-              <a:t>供应链设计与管理、数据驱动物流优化</a:t>
+              <a:t>供应链设计与管理</a:t>
+            </a:r>
+          </a:p>
+          <a:p>
+            <a:pPr algn="l">
+              <a:lnSpc>
+                <a:spcPct val="128000"/>
+              </a:lnSpc>
+              <a:spcAft>
+                <a:spcPts val="0"/>
+              </a:spcAft>
+              <a:buNone/>
+            </a:pPr>
+            <a:r>
+              <a:rPr lang="en-US" altLang="zh-CN" sz="800" b="0" i="0" dirty="0">
+                <a:solidFill>
+                  <a:srgbClr val="5B5D72"/>
+                </a:solidFill>
+                <a:latin typeface="Arial"/>
+                <a:ea typeface="Microsoft YaHei"/>
+                <a:cs typeface="Arial"/>
+              </a:rPr>
+              <a:t>数据驱动物流优化</a:t>
             </a:r>
           </a:p>
         </p:txBody>
@@ -5567,12 +5765,12 @@
         </p:nvSpPr>
         <p:spPr>
           <a:xfrm>
-            <a:off x="7287585" y="3694176"/>
-            <a:ext cx="2109155" cy="1024128"/>
+            <a:off x="7287585" y="3675888"/>
+            <a:ext cx="2109155" cy="1060704"/>
           </a:xfrm>
           <a:prstGeom prst="roundRect">
             <a:avLst>
-              <a:gd name="adj" fmla="val 8000"/>
+              <a:gd name="adj" fmla="val 7000"/>
             </a:avLst>
           </a:prstGeom>
           <a:solidFill>
@@ -5609,8 +5807,8 @@
         </p:blipFill>
         <p:spPr>
           <a:xfrm>
-            <a:off x="7397313" y="3767328"/>
-            <a:ext cx="786384" cy="786384"/>
+            <a:off x="7406457" y="3785616"/>
+            <a:ext cx="676656" cy="676656"/>
           </a:xfrm>
           <a:prstGeom prst="ellipse">
             <a:avLst/>
@@ -5630,8 +5828,8 @@
         </p:nvSpPr>
         <p:spPr>
           <a:xfrm>
-            <a:off x="7571049" y="4462272"/>
-            <a:ext cx="438912" cy="192024"/>
+            <a:off x="7552761" y="4370832"/>
+            <a:ext cx="384048" cy="173736"/>
           </a:xfrm>
           <a:prstGeom prst="roundRect">
             <a:avLst>
@@ -5658,7 +5856,7 @@
               <a:buNone/>
             </a:pPr>
             <a:r>
-              <a:rPr lang="en-US" altLang="zh-CN" sz="900" b="1" i="0" dirty="0">
+              <a:rPr lang="en-US" altLang="zh-CN" sz="800" b="1" i="0" spc="100" dirty="0">
                 <a:solidFill>
                   <a:srgbClr val="FFFFFF"/>
                 </a:solidFill>
@@ -5679,8 +5877,8 @@
         </p:nvSpPr>
         <p:spPr>
           <a:xfrm>
-            <a:off x="8265993" y="3749040"/>
-            <a:ext cx="1057595" cy="914400"/>
+            <a:off x="8192841" y="3749040"/>
+            <a:ext cx="1139891" cy="914400"/>
           </a:xfrm>
           <a:prstGeom prst="rect">
             <a:avLst/>
@@ -5698,12 +5896,12 @@
           <a:p>
             <a:pPr algn="l">
               <a:spcAft>
-                <a:spcPts val="200"/>
-              </a:spcAft>
-              <a:buNone/>
-            </a:pPr>
-            <a:r>
-              <a:rPr lang="en-US" altLang="zh-CN" sz="1300" b="1" i="0" dirty="0">
+                <a:spcPts val="300"/>
+              </a:spcAft>
+              <a:buNone/>
+            </a:pPr>
+            <a:r>
+              <a:rPr lang="en-US" altLang="zh-CN" sz="1250" b="1" i="0" spc="20" dirty="0">
                 <a:solidFill>
                   <a:srgbClr val="1E1E2E"/>
                 </a:solidFill>
@@ -5717,17 +5915,17 @@
           <a:p>
             <a:pPr algn="l">
               <a:lnSpc>
-                <a:spcPct val="95000"/>
+                <a:spcPct val="128000"/>
               </a:lnSpc>
               <a:spcAft>
-                <a:spcPts val="0"/>
-              </a:spcAft>
-              <a:buNone/>
-            </a:pPr>
-            <a:r>
-              <a:rPr lang="en-US" altLang="zh-CN" sz="900" b="1" i="0" dirty="0">
-                <a:solidFill>
-                  <a:srgbClr val="2E3192"/>
+                <a:spcPts val="200"/>
+              </a:spcAft>
+              <a:buNone/>
+            </a:pPr>
+            <a:r>
+              <a:rPr lang="en-US" altLang="zh-CN" sz="800" b="0" i="0" dirty="0">
+                <a:solidFill>
+                  <a:srgbClr val="4245AF"/>
                 </a:solidFill>
                 <a:latin typeface="Arial"/>
                 <a:ea typeface="Microsoft YaHei"/>
@@ -5739,7 +5937,7 @@
           <a:p>
             <a:pPr algn="l">
               <a:lnSpc>
-                <a:spcPct val="95000"/>
+                <a:spcPct val="128000"/>
               </a:lnSpc>
               <a:spcAft>
                 <a:spcPts val="0"/>
@@ -5747,7 +5945,7 @@
               <a:buNone/>
             </a:pPr>
             <a:r>
-              <a:rPr lang="en-US" altLang="zh-CN" sz="900" b="0" i="0" dirty="0">
+              <a:rPr lang="en-US" altLang="zh-CN" sz="800" b="0" i="0" dirty="0">
                 <a:solidFill>
                   <a:srgbClr val="5B5D72"/>
                 </a:solidFill>
@@ -5755,7 +5953,29 @@
                 <a:ea typeface="Microsoft YaHei"/>
                 <a:cs typeface="Arial"/>
               </a:rPr>
-              <a:t>地球关键带过程与生态功能</a:t>
+              <a:t>地球关键带过程</a:t>
+            </a:r>
+          </a:p>
+          <a:p>
+            <a:pPr algn="l">
+              <a:lnSpc>
+                <a:spcPct val="128000"/>
+              </a:lnSpc>
+              <a:spcAft>
+                <a:spcPts val="0"/>
+              </a:spcAft>
+              <a:buNone/>
+            </a:pPr>
+            <a:r>
+              <a:rPr lang="en-US" altLang="zh-CN" sz="800" b="0" i="0" dirty="0">
+                <a:solidFill>
+                  <a:srgbClr val="5B5D72"/>
+                </a:solidFill>
+                <a:latin typeface="Arial"/>
+                <a:ea typeface="Microsoft YaHei"/>
+                <a:cs typeface="Arial"/>
+              </a:rPr>
+              <a:t>与生态功能</a:t>
             </a:r>
           </a:p>
         </p:txBody>
@@ -5768,12 +5988,12 @@
         </p:nvSpPr>
         <p:spPr>
           <a:xfrm>
-            <a:off x="9533900" y="3694176"/>
-            <a:ext cx="2109155" cy="1024128"/>
+            <a:off x="9533900" y="3675888"/>
+            <a:ext cx="2109155" cy="1060704"/>
           </a:xfrm>
           <a:prstGeom prst="roundRect">
             <a:avLst>
-              <a:gd name="adj" fmla="val 8000"/>
+              <a:gd name="adj" fmla="val 7000"/>
             </a:avLst>
           </a:prstGeom>
           <a:solidFill>
@@ -5810,8 +6030,8 @@
         </p:blipFill>
         <p:spPr>
           <a:xfrm>
-            <a:off x="9643628" y="3767328"/>
-            <a:ext cx="786384" cy="786384"/>
+            <a:off x="9652772" y="3785616"/>
+            <a:ext cx="676656" cy="676656"/>
           </a:xfrm>
           <a:prstGeom prst="ellipse">
             <a:avLst/>
@@ -5831,8 +6051,8 @@
         </p:nvSpPr>
         <p:spPr>
           <a:xfrm>
-            <a:off x="9817364" y="4462272"/>
-            <a:ext cx="438912" cy="192024"/>
+            <a:off x="9799076" y="4370832"/>
+            <a:ext cx="384048" cy="173736"/>
           </a:xfrm>
           <a:prstGeom prst="roundRect">
             <a:avLst>
@@ -5859,7 +6079,7 @@
               <a:buNone/>
             </a:pPr>
             <a:r>
-              <a:rPr lang="en-US" altLang="zh-CN" sz="900" b="1" i="0" dirty="0">
+              <a:rPr lang="en-US" altLang="zh-CN" sz="800" b="1" i="0" spc="100" dirty="0">
                 <a:solidFill>
                   <a:srgbClr val="FFFFFF"/>
                 </a:solidFill>
@@ -5880,8 +6100,8 @@
         </p:nvSpPr>
         <p:spPr>
           <a:xfrm>
-            <a:off x="10512308" y="3749040"/>
-            <a:ext cx="1057595" cy="914400"/>
+            <a:off x="10439156" y="3749040"/>
+            <a:ext cx="1139891" cy="914400"/>
           </a:xfrm>
           <a:prstGeom prst="rect">
             <a:avLst/>
@@ -5899,12 +6119,12 @@
           <a:p>
             <a:pPr algn="l">
               <a:spcAft>
-                <a:spcPts val="200"/>
-              </a:spcAft>
-              <a:buNone/>
-            </a:pPr>
-            <a:r>
-              <a:rPr lang="en-US" altLang="zh-CN" sz="1300" b="1" i="0" dirty="0">
+                <a:spcPts val="300"/>
+              </a:spcAft>
+              <a:buNone/>
+            </a:pPr>
+            <a:r>
+              <a:rPr lang="en-US" altLang="zh-CN" sz="1250" b="1" i="0" spc="20" dirty="0">
                 <a:solidFill>
                   <a:srgbClr val="1E1E2E"/>
                 </a:solidFill>
@@ -5918,7 +6138,7 @@
           <a:p>
             <a:pPr algn="l">
               <a:lnSpc>
-                <a:spcPct val="95000"/>
+                <a:spcPct val="128000"/>
               </a:lnSpc>
               <a:spcAft>
                 <a:spcPts val="0"/>
@@ -5926,29 +6146,51 @@
               <a:buNone/>
             </a:pPr>
             <a:r>
-              <a:rPr lang="en-US" altLang="zh-CN" sz="900" b="1" i="0" dirty="0">
-                <a:solidFill>
-                  <a:srgbClr val="2E3192"/>
-                </a:solidFill>
-                <a:latin typeface="Arial"/>
-                <a:ea typeface="Microsoft YaHei"/>
-                <a:cs typeface="Arial"/>
-              </a:rPr>
-              <a:t>澳大利亚联邦科学与工业研究组织 CSIRO</a:t>
+              <a:rPr lang="en-US" altLang="zh-CN" sz="800" b="0" i="0" dirty="0">
+                <a:solidFill>
+                  <a:srgbClr val="4245AF"/>
+                </a:solidFill>
+                <a:latin typeface="Arial"/>
+                <a:ea typeface="Microsoft YaHei"/>
+                <a:cs typeface="Arial"/>
+              </a:rPr>
+              <a:t>澳大利亚联邦科学</a:t>
             </a:r>
           </a:p>
           <a:p>
             <a:pPr algn="l">
               <a:lnSpc>
-                <a:spcPct val="95000"/>
+                <a:spcPct val="128000"/>
               </a:lnSpc>
               <a:spcAft>
+                <a:spcPts val="200"/>
+              </a:spcAft>
+              <a:buNone/>
+            </a:pPr>
+            <a:r>
+              <a:rPr lang="en-US" altLang="zh-CN" sz="800" b="0" i="0" dirty="0">
+                <a:solidFill>
+                  <a:srgbClr val="4245AF"/>
+                </a:solidFill>
+                <a:latin typeface="Arial"/>
+                <a:ea typeface="Microsoft YaHei"/>
+                <a:cs typeface="Arial"/>
+              </a:rPr>
+              <a:t>与工业研究组织 CSIRO</a:t>
+            </a:r>
+          </a:p>
+          <a:p>
+            <a:pPr algn="l">
+              <a:lnSpc>
+                <a:spcPct val="128000"/>
+              </a:lnSpc>
+              <a:spcAft>
                 <a:spcPts val="0"/>
               </a:spcAft>
               <a:buNone/>
             </a:pPr>
             <a:r>
-              <a:rPr lang="en-US" altLang="zh-CN" sz="900" b="0" i="0" dirty="0">
+              <a:rPr lang="en-US" altLang="zh-CN" sz="800" b="0" i="0" dirty="0">
                 <a:solidFill>
                   <a:srgbClr val="5B5D72"/>
                 </a:solidFill>
@@ -5956,7 +6198,7 @@
                 <a:ea typeface="Microsoft YaHei"/>
                 <a:cs typeface="Arial"/>
               </a:rPr>
-              <a:t>气候科学、全球变化</a:t>
+              <a:t>气候科学 · 全球变化</a:t>
             </a:r>
           </a:p>
         </p:txBody>
@@ -5969,7 +6211,7 @@
         </p:nvSpPr>
         <p:spPr>
           <a:xfrm>
-            <a:off x="548640" y="4828032"/>
+            <a:off x="548640" y="4846320"/>
             <a:ext cx="7315200" cy="237744"/>
           </a:xfrm>
           <a:prstGeom prst="rect">
@@ -6025,12 +6267,12 @@
         </p:nvSpPr>
         <p:spPr>
           <a:xfrm>
-            <a:off x="548640" y="5084064"/>
-            <a:ext cx="1490864" cy="1554480"/>
+            <a:off x="548640" y="5120640"/>
+            <a:ext cx="1490864" cy="1536192"/>
           </a:xfrm>
           <a:prstGeom prst="roundRect">
             <a:avLst>
-              <a:gd name="adj" fmla="val 8000"/>
+              <a:gd name="adj" fmla="val 7000"/>
             </a:avLst>
           </a:prstGeom>
           <a:solidFill>
@@ -6067,8 +6309,8 @@
         </p:blipFill>
         <p:spPr>
           <a:xfrm>
-            <a:off x="992320" y="5157216"/>
-            <a:ext cx="603504" cy="603504"/>
+            <a:off x="1019752" y="5212080"/>
+            <a:ext cx="548640" cy="548640"/>
           </a:xfrm>
           <a:prstGeom prst="ellipse">
             <a:avLst/>
@@ -6088,7 +6330,7 @@
         </p:nvSpPr>
         <p:spPr>
           <a:xfrm>
-            <a:off x="603504" y="5788152"/>
+            <a:off x="603504" y="5797296"/>
             <a:ext cx="1381136" cy="219456"/>
           </a:xfrm>
           <a:prstGeom prst="rect">
@@ -6112,7 +6354,7 @@
               <a:buNone/>
             </a:pPr>
             <a:r>
-              <a:rPr lang="en-US" altLang="zh-CN" sz="1150" b="1" i="0" dirty="0">
+              <a:rPr lang="en-US" altLang="zh-CN" sz="1100" b="1" i="0" spc="10" dirty="0">
                 <a:solidFill>
                   <a:srgbClr val="1E1E2E"/>
                 </a:solidFill>
@@ -6133,8 +6375,8 @@
         </p:nvSpPr>
         <p:spPr>
           <a:xfrm>
-            <a:off x="621792" y="6007608"/>
-            <a:ext cx="1344560" cy="594360"/>
+            <a:off x="603504" y="6025896"/>
+            <a:ext cx="1381136" cy="594360"/>
           </a:xfrm>
           <a:prstGeom prst="rect">
             <a:avLst/>
@@ -6152,7 +6394,7 @@
           <a:p>
             <a:pPr algn="ctr">
               <a:lnSpc>
-                <a:spcPct val="90000"/>
+                <a:spcPct val="128000"/>
               </a:lnSpc>
               <a:spcAft>
                 <a:spcPts val="0"/>
@@ -6160,29 +6402,51 @@
               <a:buNone/>
             </a:pPr>
             <a:r>
-              <a:rPr lang="en-US" altLang="zh-CN" sz="850" b="1" i="0" dirty="0">
-                <a:solidFill>
-                  <a:srgbClr val="2E3192"/>
-                </a:solidFill>
-                <a:latin typeface="Arial"/>
-                <a:ea typeface="Microsoft YaHei"/>
-                <a:cs typeface="Arial"/>
-              </a:rPr>
-              <a:t>马克斯·普朗克地球人类学研究所</a:t>
+              <a:rPr lang="en-US" altLang="zh-CN" sz="750" b="0" i="0" dirty="0">
+                <a:solidFill>
+                  <a:srgbClr val="4245AF"/>
+                </a:solidFill>
+                <a:latin typeface="Arial"/>
+                <a:ea typeface="Microsoft YaHei"/>
+                <a:cs typeface="Arial"/>
+              </a:rPr>
+              <a:t>马克斯·普朗克</a:t>
             </a:r>
           </a:p>
           <a:p>
             <a:pPr algn="ctr">
               <a:lnSpc>
-                <a:spcPct val="90000"/>
+                <a:spcPct val="128000"/>
               </a:lnSpc>
               <a:spcAft>
+                <a:spcPts val="200"/>
+              </a:spcAft>
+              <a:buNone/>
+            </a:pPr>
+            <a:r>
+              <a:rPr lang="en-US" altLang="zh-CN" sz="750" b="0" i="0" dirty="0">
+                <a:solidFill>
+                  <a:srgbClr val="4245AF"/>
+                </a:solidFill>
+                <a:latin typeface="Arial"/>
+                <a:ea typeface="Microsoft YaHei"/>
+                <a:cs typeface="Arial"/>
+              </a:rPr>
+              <a:t>地球人类学研究所</a:t>
+            </a:r>
+          </a:p>
+          <a:p>
+            <a:pPr algn="ctr">
+              <a:lnSpc>
+                <a:spcPct val="128000"/>
+              </a:lnSpc>
+              <a:spcAft>
                 <a:spcPts val="0"/>
               </a:spcAft>
               <a:buNone/>
             </a:pPr>
             <a:r>
-              <a:rPr lang="en-US" altLang="zh-CN" sz="850" b="0" i="0" dirty="0">
+              <a:rPr lang="en-US" altLang="zh-CN" sz="750" b="0" i="0" dirty="0">
                 <a:solidFill>
                   <a:srgbClr val="5B5D72"/>
                 </a:solidFill>
@@ -6190,7 +6454,29 @@
                 <a:ea typeface="Microsoft YaHei"/>
                 <a:cs typeface="Arial"/>
               </a:rPr>
-              <a:t>考古科学、古生态、土地利用与城市化协同演化</a:t>
+              <a:t>考古科学 · 古生态</a:t>
+            </a:r>
+          </a:p>
+          <a:p>
+            <a:pPr algn="ctr">
+              <a:lnSpc>
+                <a:spcPct val="128000"/>
+              </a:lnSpc>
+              <a:spcAft>
+                <a:spcPts val="0"/>
+              </a:spcAft>
+              <a:buNone/>
+            </a:pPr>
+            <a:r>
+              <a:rPr lang="en-US" altLang="zh-CN" sz="750" b="0" i="0" dirty="0">
+                <a:solidFill>
+                  <a:srgbClr val="5B5D72"/>
+                </a:solidFill>
+                <a:latin typeface="Arial"/>
+                <a:ea typeface="Microsoft YaHei"/>
+                <a:cs typeface="Arial"/>
+              </a:rPr>
+              <a:t>土地利用与城市化协同演化</a:t>
             </a:r>
           </a:p>
         </p:txBody>
@@ -6203,12 +6489,12 @@
         </p:nvSpPr>
         <p:spPr>
           <a:xfrm>
-            <a:off x="2149232" y="5084064"/>
-            <a:ext cx="1490864" cy="1554480"/>
+            <a:off x="2149232" y="5120640"/>
+            <a:ext cx="1490864" cy="1536192"/>
           </a:xfrm>
           <a:prstGeom prst="roundRect">
             <a:avLst>
-              <a:gd name="adj" fmla="val 8000"/>
+              <a:gd name="adj" fmla="val 7000"/>
             </a:avLst>
           </a:prstGeom>
           <a:solidFill>
@@ -6245,8 +6531,8 @@
         </p:blipFill>
         <p:spPr>
           <a:xfrm>
-            <a:off x="2592912" y="5157216"/>
-            <a:ext cx="603504" cy="603504"/>
+            <a:off x="2620344" y="5212080"/>
+            <a:ext cx="548640" cy="548640"/>
           </a:xfrm>
           <a:prstGeom prst="ellipse">
             <a:avLst/>
@@ -6266,7 +6552,7 @@
         </p:nvSpPr>
         <p:spPr>
           <a:xfrm>
-            <a:off x="2204096" y="5788152"/>
+            <a:off x="2204096" y="5797296"/>
             <a:ext cx="1381136" cy="219456"/>
           </a:xfrm>
           <a:prstGeom prst="rect">
@@ -6290,7 +6576,7 @@
               <a:buNone/>
             </a:pPr>
             <a:r>
-              <a:rPr lang="en-US" altLang="zh-CN" sz="1150" b="1" i="0" dirty="0">
+              <a:rPr lang="en-US" altLang="zh-CN" sz="1100" b="1" i="0" spc="10" dirty="0">
                 <a:solidFill>
                   <a:srgbClr val="1E1E2E"/>
                 </a:solidFill>
@@ -6311,8 +6597,8 @@
         </p:nvSpPr>
         <p:spPr>
           <a:xfrm>
-            <a:off x="2222384" y="6007608"/>
-            <a:ext cx="1344560" cy="594360"/>
+            <a:off x="2204096" y="6025896"/>
+            <a:ext cx="1381136" cy="594360"/>
           </a:xfrm>
           <a:prstGeom prst="rect">
             <a:avLst/>
@@ -6330,17 +6616,17 @@
           <a:p>
             <a:pPr algn="ctr">
               <a:lnSpc>
-                <a:spcPct val="90000"/>
+                <a:spcPct val="128000"/>
               </a:lnSpc>
               <a:spcAft>
-                <a:spcPts val="0"/>
-              </a:spcAft>
-              <a:buNone/>
-            </a:pPr>
-            <a:r>
-              <a:rPr lang="en-US" altLang="zh-CN" sz="850" b="1" i="0" dirty="0">
-                <a:solidFill>
-                  <a:srgbClr val="2E3192"/>
+                <a:spcPts val="200"/>
+              </a:spcAft>
+              <a:buNone/>
+            </a:pPr>
+            <a:r>
+              <a:rPr lang="en-US" altLang="zh-CN" sz="750" b="0" i="0" dirty="0">
+                <a:solidFill>
+                  <a:srgbClr val="4245AF"/>
                 </a:solidFill>
                 <a:latin typeface="Arial"/>
                 <a:ea typeface="Microsoft YaHei"/>
@@ -6352,7 +6638,7 @@
           <a:p>
             <a:pPr algn="ctr">
               <a:lnSpc>
-                <a:spcPct val="90000"/>
+                <a:spcPct val="128000"/>
               </a:lnSpc>
               <a:spcAft>
                 <a:spcPts val="0"/>
@@ -6360,7 +6646,7 @@
               <a:buNone/>
             </a:pPr>
             <a:r>
-              <a:rPr lang="en-US" altLang="zh-CN" sz="850" b="0" i="0" dirty="0">
+              <a:rPr lang="en-US" altLang="zh-CN" sz="750" b="0" i="0" dirty="0">
                 <a:solidFill>
                   <a:srgbClr val="5B5D72"/>
                 </a:solidFill>
@@ -6368,7 +6654,29 @@
                 <a:ea typeface="Microsoft YaHei"/>
                 <a:cs typeface="Arial"/>
               </a:rPr>
-              <a:t>城市复杂系统、网络、城市尺度理论</a:t>
+              <a:t>城市复杂系统 · 网络</a:t>
+            </a:r>
+          </a:p>
+          <a:p>
+            <a:pPr algn="ctr">
+              <a:lnSpc>
+                <a:spcPct val="128000"/>
+              </a:lnSpc>
+              <a:spcAft>
+                <a:spcPts val="0"/>
+              </a:spcAft>
+              <a:buNone/>
+            </a:pPr>
+            <a:r>
+              <a:rPr lang="en-US" altLang="zh-CN" sz="750" b="0" i="0" dirty="0">
+                <a:solidFill>
+                  <a:srgbClr val="5B5D72"/>
+                </a:solidFill>
+                <a:latin typeface="Arial"/>
+                <a:ea typeface="Microsoft YaHei"/>
+                <a:cs typeface="Arial"/>
+              </a:rPr>
+              <a:t>城市尺度理论</a:t>
             </a:r>
           </a:p>
         </p:txBody>
@@ -6381,12 +6689,12 @@
         </p:nvSpPr>
         <p:spPr>
           <a:xfrm>
-            <a:off x="3749824" y="5084064"/>
-            <a:ext cx="1490864" cy="1554480"/>
+            <a:off x="3749824" y="5120640"/>
+            <a:ext cx="1490864" cy="1536192"/>
           </a:xfrm>
           <a:prstGeom prst="roundRect">
             <a:avLst>
-              <a:gd name="adj" fmla="val 8000"/>
+              <a:gd name="adj" fmla="val 7000"/>
             </a:avLst>
           </a:prstGeom>
           <a:solidFill>
@@ -6423,8 +6731,8 @@
         </p:blipFill>
         <p:spPr>
           <a:xfrm>
-            <a:off x="4193504" y="5157216"/>
-            <a:ext cx="603504" cy="603504"/>
+            <a:off x="4220936" y="5212080"/>
+            <a:ext cx="548640" cy="548640"/>
           </a:xfrm>
           <a:prstGeom prst="ellipse">
             <a:avLst/>
@@ -6444,7 +6752,7 @@
         </p:nvSpPr>
         <p:spPr>
           <a:xfrm>
-            <a:off x="3804688" y="5788152"/>
+            <a:off x="3804688" y="5797296"/>
             <a:ext cx="1381136" cy="219456"/>
           </a:xfrm>
           <a:prstGeom prst="rect">
@@ -6468,7 +6776,7 @@
               <a:buNone/>
             </a:pPr>
             <a:r>
-              <a:rPr lang="en-US" altLang="zh-CN" sz="1150" b="1" i="0" dirty="0">
+              <a:rPr lang="en-US" altLang="zh-CN" sz="1100" b="1" i="0" spc="10" dirty="0">
                 <a:solidFill>
                   <a:srgbClr val="1E1E2E"/>
                 </a:solidFill>
@@ -6489,8 +6797,8 @@
         </p:nvSpPr>
         <p:spPr>
           <a:xfrm>
-            <a:off x="3822976" y="6007608"/>
-            <a:ext cx="1344560" cy="594360"/>
+            <a:off x="3804688" y="6025896"/>
+            <a:ext cx="1381136" cy="594360"/>
           </a:xfrm>
           <a:prstGeom prst="rect">
             <a:avLst/>
@@ -6508,17 +6816,17 @@
           <a:p>
             <a:pPr algn="ctr">
               <a:lnSpc>
-                <a:spcPct val="90000"/>
+                <a:spcPct val="128000"/>
               </a:lnSpc>
               <a:spcAft>
-                <a:spcPts val="0"/>
-              </a:spcAft>
-              <a:buNone/>
-            </a:pPr>
-            <a:r>
-              <a:rPr lang="en-US" altLang="zh-CN" sz="850" b="1" i="0" dirty="0">
-                <a:solidFill>
-                  <a:srgbClr val="2E3192"/>
+                <a:spcPts val="200"/>
+              </a:spcAft>
+              <a:buNone/>
+            </a:pPr>
+            <a:r>
+              <a:rPr lang="en-US" altLang="zh-CN" sz="750" b="0" i="0" dirty="0">
+                <a:solidFill>
+                  <a:srgbClr val="4245AF"/>
                 </a:solidFill>
                 <a:latin typeface="Arial"/>
                 <a:ea typeface="Microsoft YaHei"/>
@@ -6530,7 +6838,7 @@
           <a:p>
             <a:pPr algn="ctr">
               <a:lnSpc>
-                <a:spcPct val="90000"/>
+                <a:spcPct val="128000"/>
               </a:lnSpc>
               <a:spcAft>
                 <a:spcPts val="0"/>
@@ -6538,7 +6846,7 @@
               <a:buNone/>
             </a:pPr>
             <a:r>
-              <a:rPr lang="en-US" altLang="zh-CN" sz="850" b="0" i="0" dirty="0">
+              <a:rPr lang="en-US" altLang="zh-CN" sz="750" b="0" i="0" dirty="0">
                 <a:solidFill>
                   <a:srgbClr val="5B5D72"/>
                 </a:solidFill>
@@ -6546,7 +6854,29 @@
                 <a:ea typeface="Microsoft YaHei"/>
                 <a:cs typeface="Arial"/>
               </a:rPr>
-              <a:t>住房与建成环境、流行病学、城市健康</a:t>
+              <a:t>住房与建成环境 · 流行病学</a:t>
+            </a:r>
+          </a:p>
+          <a:p>
+            <a:pPr algn="ctr">
+              <a:lnSpc>
+                <a:spcPct val="128000"/>
+              </a:lnSpc>
+              <a:spcAft>
+                <a:spcPts val="0"/>
+              </a:spcAft>
+              <a:buNone/>
+            </a:pPr>
+            <a:r>
+              <a:rPr lang="en-US" altLang="zh-CN" sz="750" b="0" i="0" dirty="0">
+                <a:solidFill>
+                  <a:srgbClr val="5B5D72"/>
+                </a:solidFill>
+                <a:latin typeface="Arial"/>
+                <a:ea typeface="Microsoft YaHei"/>
+                <a:cs typeface="Arial"/>
+              </a:rPr>
+              <a:t>城市健康</a:t>
             </a:r>
           </a:p>
         </p:txBody>
@@ -6559,12 +6889,12 @@
         </p:nvSpPr>
         <p:spPr>
           <a:xfrm>
-            <a:off x="5350416" y="5084064"/>
-            <a:ext cx="1490864" cy="1554480"/>
+            <a:off x="5350416" y="5120640"/>
+            <a:ext cx="1490864" cy="1536192"/>
           </a:xfrm>
           <a:prstGeom prst="roundRect">
             <a:avLst>
-              <a:gd name="adj" fmla="val 8000"/>
+              <a:gd name="adj" fmla="val 7000"/>
             </a:avLst>
           </a:prstGeom>
           <a:solidFill>
@@ -6601,8 +6931,8 @@
         </p:blipFill>
         <p:spPr>
           <a:xfrm>
-            <a:off x="5794096" y="5157216"/>
-            <a:ext cx="603504" cy="603504"/>
+            <a:off x="5821528" y="5212080"/>
+            <a:ext cx="548640" cy="548640"/>
           </a:xfrm>
           <a:prstGeom prst="ellipse">
             <a:avLst/>
@@ -6622,7 +6952,7 @@
         </p:nvSpPr>
         <p:spPr>
           <a:xfrm>
-            <a:off x="5405280" y="5788152"/>
+            <a:off x="5405280" y="5797296"/>
             <a:ext cx="1381136" cy="219456"/>
           </a:xfrm>
           <a:prstGeom prst="rect">
@@ -6646,7 +6976,7 @@
               <a:buNone/>
             </a:pPr>
             <a:r>
-              <a:rPr lang="en-US" altLang="zh-CN" sz="1150" b="1" i="0" dirty="0">
+              <a:rPr lang="en-US" altLang="zh-CN" sz="1100" b="1" i="0" spc="10" dirty="0">
                 <a:solidFill>
                   <a:srgbClr val="1E1E2E"/>
                 </a:solidFill>
@@ -6667,8 +6997,8 @@
         </p:nvSpPr>
         <p:spPr>
           <a:xfrm>
-            <a:off x="5423568" y="6007608"/>
-            <a:ext cx="1344560" cy="594360"/>
+            <a:off x="5405280" y="6025896"/>
+            <a:ext cx="1381136" cy="594360"/>
           </a:xfrm>
           <a:prstGeom prst="rect">
             <a:avLst/>
@@ -6686,17 +7016,17 @@
           <a:p>
             <a:pPr algn="ctr">
               <a:lnSpc>
-                <a:spcPct val="90000"/>
+                <a:spcPct val="128000"/>
               </a:lnSpc>
               <a:spcAft>
-                <a:spcPts val="0"/>
-              </a:spcAft>
-              <a:buNone/>
-            </a:pPr>
-            <a:r>
-              <a:rPr lang="en-US" altLang="zh-CN" sz="850" b="1" i="0" dirty="0">
-                <a:solidFill>
-                  <a:srgbClr val="2E3192"/>
+                <a:spcPts val="200"/>
+              </a:spcAft>
+              <a:buNone/>
+            </a:pPr>
+            <a:r>
+              <a:rPr lang="en-US" altLang="zh-CN" sz="750" b="0" i="0" dirty="0">
+                <a:solidFill>
+                  <a:srgbClr val="4245AF"/>
                 </a:solidFill>
                 <a:latin typeface="Arial"/>
                 <a:ea typeface="Microsoft YaHei"/>
@@ -6708,7 +7038,7 @@
           <a:p>
             <a:pPr algn="ctr">
               <a:lnSpc>
-                <a:spcPct val="90000"/>
+                <a:spcPct val="128000"/>
               </a:lnSpc>
               <a:spcAft>
                 <a:spcPts val="0"/>
@@ -6716,7 +7046,7 @@
               <a:buNone/>
             </a:pPr>
             <a:r>
-              <a:rPr lang="en-US" altLang="zh-CN" sz="850" b="0" i="0" dirty="0">
+              <a:rPr lang="en-US" altLang="zh-CN" sz="750" b="0" i="0" dirty="0">
                 <a:solidFill>
                   <a:srgbClr val="5B5D72"/>
                 </a:solidFill>
@@ -6737,12 +7067,12 @@
         </p:nvSpPr>
         <p:spPr>
           <a:xfrm>
-            <a:off x="6951008" y="5084064"/>
-            <a:ext cx="1490864" cy="1554480"/>
+            <a:off x="6951008" y="5120640"/>
+            <a:ext cx="1490864" cy="1536192"/>
           </a:xfrm>
           <a:prstGeom prst="roundRect">
             <a:avLst>
-              <a:gd name="adj" fmla="val 8000"/>
+              <a:gd name="adj" fmla="val 7000"/>
             </a:avLst>
           </a:prstGeom>
           <a:solidFill>
@@ -6779,8 +7109,8 @@
         </p:blipFill>
         <p:spPr>
           <a:xfrm>
-            <a:off x="7394687" y="5157216"/>
-            <a:ext cx="603504" cy="603504"/>
+            <a:off x="7422119" y="5212080"/>
+            <a:ext cx="548640" cy="548640"/>
           </a:xfrm>
           <a:prstGeom prst="ellipse">
             <a:avLst/>
@@ -6800,7 +7130,7 @@
         </p:nvSpPr>
         <p:spPr>
           <a:xfrm>
-            <a:off x="7005872" y="5788152"/>
+            <a:off x="7005872" y="5797296"/>
             <a:ext cx="1381136" cy="219456"/>
           </a:xfrm>
           <a:prstGeom prst="rect">
@@ -6824,7 +7154,7 @@
               <a:buNone/>
             </a:pPr>
             <a:r>
-              <a:rPr lang="en-US" altLang="zh-CN" sz="1150" b="1" i="0" dirty="0">
+              <a:rPr lang="en-US" altLang="zh-CN" sz="1100" b="1" i="0" spc="10" dirty="0">
                 <a:solidFill>
                   <a:srgbClr val="1E1E2E"/>
                 </a:solidFill>
@@ -6845,8 +7175,8 @@
         </p:nvSpPr>
         <p:spPr>
           <a:xfrm>
-            <a:off x="7024160" y="6007608"/>
-            <a:ext cx="1344560" cy="594360"/>
+            <a:off x="7005872" y="6025896"/>
+            <a:ext cx="1381136" cy="594360"/>
           </a:xfrm>
           <a:prstGeom prst="rect">
             <a:avLst/>
@@ -6864,17 +7194,17 @@
           <a:p>
             <a:pPr algn="ctr">
               <a:lnSpc>
-                <a:spcPct val="90000"/>
+                <a:spcPct val="128000"/>
               </a:lnSpc>
               <a:spcAft>
-                <a:spcPts val="0"/>
-              </a:spcAft>
-              <a:buNone/>
-            </a:pPr>
-            <a:r>
-              <a:rPr lang="en-US" altLang="zh-CN" sz="850" b="1" i="0" dirty="0">
-                <a:solidFill>
-                  <a:srgbClr val="2E3192"/>
+                <a:spcPts val="200"/>
+              </a:spcAft>
+              <a:buNone/>
+            </a:pPr>
+            <a:r>
+              <a:rPr lang="en-US" altLang="zh-CN" sz="750" b="0" i="0" dirty="0">
+                <a:solidFill>
+                  <a:srgbClr val="4245AF"/>
                 </a:solidFill>
                 <a:latin typeface="Arial"/>
                 <a:ea typeface="Microsoft YaHei"/>
@@ -6886,7 +7216,7 @@
           <a:p>
             <a:pPr algn="ctr">
               <a:lnSpc>
-                <a:spcPct val="90000"/>
+                <a:spcPct val="128000"/>
               </a:lnSpc>
               <a:spcAft>
                 <a:spcPts val="0"/>
@@ -6894,7 +7224,7 @@
               <a:buNone/>
             </a:pPr>
             <a:r>
-              <a:rPr lang="en-US" altLang="zh-CN" sz="850" b="0" i="0" dirty="0">
+              <a:rPr lang="en-US" altLang="zh-CN" sz="750" b="0" i="0" dirty="0">
                 <a:solidFill>
                   <a:srgbClr val="5B5D72"/>
                 </a:solidFill>
@@ -6902,7 +7232,7 @@
                 <a:ea typeface="Microsoft YaHei"/>
                 <a:cs typeface="Arial"/>
               </a:rPr>
-              <a:t>智慧城市，数字平台治理</a:t>
+              <a:t>智慧城市 · 数字平台治理</a:t>
             </a:r>
           </a:p>
         </p:txBody>
@@ -6915,12 +7245,12 @@
         </p:nvSpPr>
         <p:spPr>
           <a:xfrm>
-            <a:off x="8551599" y="5084064"/>
-            <a:ext cx="1490864" cy="1554480"/>
+            <a:off x="8551599" y="5120640"/>
+            <a:ext cx="1490864" cy="1536192"/>
           </a:xfrm>
           <a:prstGeom prst="roundRect">
             <a:avLst>
-              <a:gd name="adj" fmla="val 8000"/>
+              <a:gd name="adj" fmla="val 7000"/>
             </a:avLst>
           </a:prstGeom>
           <a:solidFill>
@@ -6957,8 +7287,8 @@
         </p:blipFill>
         <p:spPr>
           <a:xfrm>
-            <a:off x="8995279" y="5157216"/>
-            <a:ext cx="603504" cy="603504"/>
+            <a:off x="9022711" y="5212080"/>
+            <a:ext cx="548640" cy="548640"/>
           </a:xfrm>
           <a:prstGeom prst="ellipse">
             <a:avLst/>
@@ -6978,7 +7308,7 @@
         </p:nvSpPr>
         <p:spPr>
           <a:xfrm>
-            <a:off x="8606463" y="5788152"/>
+            <a:off x="8606463" y="5797296"/>
             <a:ext cx="1381136" cy="219456"/>
           </a:xfrm>
           <a:prstGeom prst="rect">
@@ -7002,7 +7332,7 @@
               <a:buNone/>
             </a:pPr>
             <a:r>
-              <a:rPr lang="en-US" altLang="zh-CN" sz="1150" b="1" i="0" dirty="0">
+              <a:rPr lang="en-US" altLang="zh-CN" sz="1100" b="1" i="0" spc="10" dirty="0">
                 <a:solidFill>
                   <a:srgbClr val="1E1E2E"/>
                 </a:solidFill>
@@ -7023,8 +7353,8 @@
         </p:nvSpPr>
         <p:spPr>
           <a:xfrm>
-            <a:off x="8624751" y="6007608"/>
-            <a:ext cx="1344560" cy="594360"/>
+            <a:off x="8606463" y="6025896"/>
+            <a:ext cx="1381136" cy="594360"/>
           </a:xfrm>
           <a:prstGeom prst="rect">
             <a:avLst/>
@@ -7042,17 +7372,17 @@
           <a:p>
             <a:pPr algn="ctr">
               <a:lnSpc>
-                <a:spcPct val="90000"/>
+                <a:spcPct val="128000"/>
               </a:lnSpc>
               <a:spcAft>
-                <a:spcPts val="0"/>
-              </a:spcAft>
-              <a:buNone/>
-            </a:pPr>
-            <a:r>
-              <a:rPr lang="en-US" altLang="zh-CN" sz="850" b="1" i="0" dirty="0">
-                <a:solidFill>
-                  <a:srgbClr val="2E3192"/>
+                <a:spcPts val="200"/>
+              </a:spcAft>
+              <a:buNone/>
+            </a:pPr>
+            <a:r>
+              <a:rPr lang="en-US" altLang="zh-CN" sz="750" b="0" i="0" dirty="0">
+                <a:solidFill>
+                  <a:srgbClr val="4245AF"/>
                 </a:solidFill>
                 <a:latin typeface="Arial"/>
                 <a:ea typeface="Microsoft YaHei"/>
@@ -7064,7 +7394,7 @@
           <a:p>
             <a:pPr algn="ctr">
               <a:lnSpc>
-                <a:spcPct val="90000"/>
+                <a:spcPct val="128000"/>
               </a:lnSpc>
               <a:spcAft>
                 <a:spcPts val="0"/>
@@ -7072,7 +7402,7 @@
               <a:buNone/>
             </a:pPr>
             <a:r>
-              <a:rPr lang="en-US" altLang="zh-CN" sz="850" b="0" i="0" dirty="0">
+              <a:rPr lang="en-US" altLang="zh-CN" sz="750" b="0" i="0" dirty="0">
                 <a:solidFill>
                   <a:srgbClr val="5B5D72"/>
                 </a:solidFill>
@@ -7080,7 +7410,7 @@
                 <a:ea typeface="Microsoft YaHei"/>
                 <a:cs typeface="Arial"/>
               </a:rPr>
-              <a:t>智慧能源、电动交通</a:t>
+              <a:t>智慧能源 · 电动交通</a:t>
             </a:r>
           </a:p>
         </p:txBody>
@@ -7093,12 +7423,12 @@
         </p:nvSpPr>
         <p:spPr>
           <a:xfrm>
-            <a:off x="10152191" y="5084064"/>
-            <a:ext cx="1490864" cy="1554480"/>
+            <a:off x="10152191" y="5120640"/>
+            <a:ext cx="1490864" cy="1536192"/>
           </a:xfrm>
           <a:prstGeom prst="roundRect">
             <a:avLst>
-              <a:gd name="adj" fmla="val 8000"/>
+              <a:gd name="adj" fmla="val 7000"/>
             </a:avLst>
           </a:prstGeom>
           <a:solidFill>
@@ -7135,8 +7465,8 @@
         </p:blipFill>
         <p:spPr>
           <a:xfrm>
-            <a:off x="10595871" y="5157216"/>
-            <a:ext cx="603504" cy="603504"/>
+            <a:off x="10623303" y="5212080"/>
+            <a:ext cx="548640" cy="548640"/>
           </a:xfrm>
           <a:prstGeom prst="ellipse">
             <a:avLst/>
@@ -7156,7 +7486,7 @@
         </p:nvSpPr>
         <p:spPr>
           <a:xfrm>
-            <a:off x="10207055" y="5788152"/>
+            <a:off x="10207055" y="5797296"/>
             <a:ext cx="1381136" cy="219456"/>
           </a:xfrm>
           <a:prstGeom prst="rect">
@@ -7180,7 +7510,7 @@
               <a:buNone/>
             </a:pPr>
             <a:r>
-              <a:rPr lang="en-US" altLang="zh-CN" sz="1150" b="1" i="0" dirty="0">
+              <a:rPr lang="en-US" altLang="zh-CN" sz="1100" b="1" i="0" spc="10" dirty="0">
                 <a:solidFill>
                   <a:srgbClr val="1E1E2E"/>
                 </a:solidFill>
@@ -7201,8 +7531,8 @@
         </p:nvSpPr>
         <p:spPr>
           <a:xfrm>
-            <a:off x="10225343" y="6007608"/>
-            <a:ext cx="1344560" cy="594360"/>
+            <a:off x="10207055" y="6025896"/>
+            <a:ext cx="1381136" cy="594360"/>
           </a:xfrm>
           <a:prstGeom prst="rect">
             <a:avLst/>
@@ -7220,17 +7550,17 @@
           <a:p>
             <a:pPr algn="ctr">
               <a:lnSpc>
-                <a:spcPct val="90000"/>
+                <a:spcPct val="128000"/>
               </a:lnSpc>
               <a:spcAft>
-                <a:spcPts val="0"/>
-              </a:spcAft>
-              <a:buNone/>
-            </a:pPr>
-            <a:r>
-              <a:rPr lang="en-US" altLang="zh-CN" sz="850" b="1" i="0" dirty="0">
-                <a:solidFill>
-                  <a:srgbClr val="2E3192"/>
+                <a:spcPts val="200"/>
+              </a:spcAft>
+              <a:buNone/>
+            </a:pPr>
+            <a:r>
+              <a:rPr lang="en-US" altLang="zh-CN" sz="750" b="0" i="0" dirty="0">
+                <a:solidFill>
+                  <a:srgbClr val="4245AF"/>
                 </a:solidFill>
                 <a:latin typeface="Arial"/>
                 <a:ea typeface="Microsoft YaHei"/>
@@ -7242,7 +7572,7 @@
           <a:p>
             <a:pPr algn="ctr">
               <a:lnSpc>
-                <a:spcPct val="90000"/>
+                <a:spcPct val="128000"/>
               </a:lnSpc>
               <a:spcAft>
                 <a:spcPts val="0"/>
@@ -7250,7 +7580,7 @@
               <a:buNone/>
             </a:pPr>
             <a:r>
-              <a:rPr lang="en-US" altLang="zh-CN" sz="850" b="0" i="0" dirty="0">
+              <a:rPr lang="en-US" altLang="zh-CN" sz="750" b="0" i="0" dirty="0">
                 <a:solidFill>
                   <a:srgbClr val="5B5D72"/>
                 </a:solidFill>
@@ -7258,7 +7588,29 @@
                 <a:ea typeface="Microsoft YaHei"/>
                 <a:cs typeface="Arial"/>
               </a:rPr>
-              <a:t>地理信息科学、遥感和空间数据分析</a:t>
+              <a:t>地理信息科学</a:t>
+            </a:r>
+          </a:p>
+          <a:p>
+            <a:pPr algn="ctr">
+              <a:lnSpc>
+                <a:spcPct val="128000"/>
+              </a:lnSpc>
+              <a:spcAft>
+                <a:spcPts val="0"/>
+              </a:spcAft>
+              <a:buNone/>
+            </a:pPr>
+            <a:r>
+              <a:rPr lang="en-US" altLang="zh-CN" sz="750" b="0" i="0" dirty="0">
+                <a:solidFill>
+                  <a:srgbClr val="5B5D72"/>
+                </a:solidFill>
+                <a:latin typeface="Arial"/>
+                <a:ea typeface="Microsoft YaHei"/>
+                <a:cs typeface="Arial"/>
+              </a:rPr>
+              <a:t>遥感和空间数据分析</a:t>
             </a:r>
           </a:p>
         </p:txBody>

</xml_diff>